<commit_message>
Final video script (VO + image/animation prompts), live deployment details, refreshed report, deck and AI usage
Team 204 (code AYUCK), Cycle 3 grades 9-12.

Co-Authored-By: Claude Sonnet 5.5 <noreply@anthropic.com>
</commit_message>
<xml_diff>
--- a/presentation/WASL-Arena-30-Slides.pptx
+++ b/presentation/WASL-Arena-30-Slides.pptx
@@ -1931,7 +1931,7 @@
           <a:lstStyle/>
           <a:p>
             <a:r>
-              <a:t>Frontend deploys from GitHub to Vercel; backend runs on Render because video processing needs Python, FFmpeg and OpenCV. The API URL is an environment variable, and all credentials stay server-side. See the README for the live URLs once connected.</a:t>
+              <a:t>The frontend is deployed from GitHub to Vercel; the judge runs on Render because video processing needs Python, FFmpeg and OpenCV. The frontend reaches the judge through an environment variable and all credentials stay on the server. We verified the live deployment: routes load, the header badge says AI judge online, a Falaj clip uploaded to the live judge was scored 11 with a valid seal, and CORS accepts only the Vercel origin. Free tier hosting sleeps when idle, so the first request can take about 30 seconds.</a:t>
             </a:r>
           </a:p>
         </p:txBody>
@@ -8282,8 +8282,8 @@
         </p:nvSpPr>
         <p:spPr>
           <a:xfrm>
-            <a:off x="548640" y="5120640"/>
-            <a:ext cx="10972800" cy="1371600"/>
+            <a:off x="548640" y="5486400"/>
+            <a:ext cx="10972800" cy="914400"/>
           </a:xfrm>
           <a:prstGeom prst="rect">
             <a:avLst/>
@@ -8302,7 +8302,7 @@
               </a:spcAft>
             </a:pPr>
             <a:r>
-              <a:rPr sz="1100">
+              <a:rPr sz="900">
                 <a:solidFill>
                   <a:srgbClr val="C6A36B"/>
                 </a:solidFill>
@@ -8310,7 +8310,7 @@
               <a:t>◆  </a:t>
             </a:r>
             <a:r>
-              <a:rPr sz="1700" b="0">
+              <a:rPr sz="1500" b="0">
                 <a:solidFill>
                   <a:srgbClr val="26313C"/>
                 </a:solidFill>
@@ -8319,7 +8319,7 @@
               <a:t>Rule FB-1: ball observed entering the goal zone after being seen outside: </a:t>
             </a:r>
             <a:r>
-              <a:rPr sz="1700" b="1">
+              <a:rPr sz="1500" b="1">
                 <a:solidFill>
                   <a:srgbClr val="26313C"/>
                 </a:solidFill>
@@ -8327,32 +8327,17 @@
               </a:rPr>
               <a:t>+1</a:t>
             </a:r>
-          </a:p>
-          <a:p>
-            <a:pPr>
-              <a:spcAft>
-                <a:spcPts val="800"/>
-              </a:spcAft>
-            </a:pPr>
-            <a:r>
-              <a:rPr sz="1100">
-                <a:solidFill>
-                  <a:srgbClr val="C6A36B"/>
-                </a:solidFill>
-              </a:rPr>
-              <a:t>◆  </a:t>
-            </a:r>
-            <a:r>
-              <a:rPr sz="1700" b="0">
-                <a:solidFill>
-                  <a:srgbClr val="26313C"/>
-                </a:solidFill>
-                <a:latin typeface="Calibri"/>
-              </a:rPr>
-              <a:t>Ball lost near the goal → </a:t>
-            </a:r>
-            <a:r>
-              <a:rPr sz="1700" b="1">
+            <a:r>
+              <a:rPr sz="1500" b="0">
+                <a:solidFill>
+                  <a:srgbClr val="26313C"/>
+                </a:solidFill>
+                <a:latin typeface="Calibri"/>
+              </a:rPr>
+              <a:t>   ·   Ball lost near the goal → </a:t>
+            </a:r>
+            <a:r>
+              <a:rPr sz="1500" b="1">
                 <a:solidFill>
                   <a:srgbClr val="26313C"/>
                 </a:solidFill>
@@ -8361,7 +8346,7 @@
               <a:t>POSSIBLE_GOAL</a:t>
             </a:r>
             <a:r>
-              <a:rPr sz="1700" b="0">
+              <a:rPr sz="1500" b="0">
                 <a:solidFill>
                   <a:srgbClr val="26313C"/>
                 </a:solidFill>
@@ -19076,7 +19061,7 @@
                 </a:solidFill>
                 <a:latin typeface="Calibri"/>
               </a:rPr>
-              <a:t>Repository wasl-arena: frontend, backend, tests, docs, AI-usage records</a:t>
+              <a:t>MayMourad/wasl-arena (private): frontend, backend, tests, docs, AI-usage records</a:t>
             </a:r>
           </a:p>
         </p:txBody>
@@ -19159,7 +19144,7 @@
                 </a:solidFill>
                 <a:latin typeface="Cambria"/>
               </a:rPr>
-              <a:t>Vercel</a:t>
+              <a:t>Vercel · frontend</a:t>
             </a:r>
           </a:p>
         </p:txBody>
@@ -19194,7 +19179,7 @@
                 </a:solidFill>
                 <a:latin typeface="Calibri"/>
               </a:rPr>
-              <a:t>Frontend build · vercel.json · VITE_API_URL</a:t>
+              <a:t>frontend-three-fawn-47.vercel.app · VITE_API_URL points at the judge</a:t>
             </a:r>
           </a:p>
         </p:txBody>
@@ -19277,7 +19262,7 @@
                 </a:solidFill>
                 <a:latin typeface="Cambria"/>
               </a:rPr>
-              <a:t>Render</a:t>
+              <a:t>Render · AI judge</a:t>
             </a:r>
           </a:p>
         </p:txBody>
@@ -19312,7 +19297,7 @@
                 </a:solidFill>
                 <a:latin typeface="Calibri"/>
               </a:rPr>
-              <a:t>FastAPI judge · render.yaml · secrets as env vars</a:t>
+              <a:t>wasl-arena.onrender.com · FastAPI + FFmpeg + OpenCV · secrets as env vars</a:t>
             </a:r>
           </a:p>
         </p:txBody>
@@ -19325,8 +19310,8 @@
         </p:nvSpPr>
         <p:spPr>
           <a:xfrm>
-            <a:off x="548640" y="4480560"/>
-            <a:ext cx="10972800" cy="1828800"/>
+            <a:off x="548640" y="4389120"/>
+            <a:ext cx="10972800" cy="2011680"/>
           </a:xfrm>
           <a:prstGeom prst="rect">
             <a:avLst/>
@@ -19345,7 +19330,7 @@
               </a:spcAft>
             </a:pPr>
             <a:r>
-              <a:rPr sz="1300">
+              <a:rPr sz="1200">
                 <a:solidFill>
                   <a:srgbClr val="C6A36B"/>
                 </a:solidFill>
@@ -19353,13 +19338,22 @@
               <a:t>◆  </a:t>
             </a:r>
             <a:r>
-              <a:rPr sz="1900" b="0">
-                <a:solidFill>
-                  <a:srgbClr val="26313C"/>
-                </a:solidFill>
-                <a:latin typeface="Calibri"/>
-              </a:rPr>
-              <a:t>Production build verified locally; configuration prepared</a:t>
+              <a:rPr sz="1800" b="1">
+                <a:solidFill>
+                  <a:srgbClr val="26313C"/>
+                </a:solidFill>
+                <a:latin typeface="Calibri"/>
+              </a:rPr>
+              <a:t>Verified live:</a:t>
+            </a:r>
+            <a:r>
+              <a:rPr sz="1800" b="0">
+                <a:solidFill>
+                  <a:srgbClr val="26313C"/>
+                </a:solidFill>
+                <a:latin typeface="Calibri"/>
+              </a:rPr>
+              <a:t> all routes load, badge shows “AI judge online”, a Falaj clip judged on the live backend = 11 pts, seal valid</a:t>
             </a:r>
           </a:p>
           <a:p>
@@ -19369,7 +19363,7 @@
               </a:spcAft>
             </a:pPr>
             <a:r>
-              <a:rPr sz="1300">
+              <a:rPr sz="1200">
                 <a:solidFill>
                   <a:srgbClr val="C6A36B"/>
                 </a:solidFill>
@@ -19377,22 +19371,13 @@
               <a:t>◆  </a:t>
             </a:r>
             <a:r>
-              <a:rPr sz="1900" b="1">
-                <a:solidFill>
-                  <a:srgbClr val="26313C"/>
-                </a:solidFill>
-                <a:latin typeface="Calibri"/>
-              </a:rPr>
-              <a:t>Live URLs:</a:t>
-            </a:r>
-            <a:r>
-              <a:rPr sz="1900" b="0">
-                <a:solidFill>
-                  <a:srgbClr val="26313C"/>
-                </a:solidFill>
-                <a:latin typeface="Calibri"/>
-              </a:rPr>
-              <a:t> see README (published only when verified)</a:t>
+              <a:rPr sz="1800" b="0">
+                <a:solidFill>
+                  <a:srgbClr val="26313C"/>
+                </a:solidFill>
+                <a:latin typeface="Calibri"/>
+              </a:rPr>
+              <a:t>CORS locked to the Vercel origin · no secrets in the repository (.env git-ignored)</a:t>
             </a:r>
           </a:p>
           <a:p>
@@ -19402,7 +19387,7 @@
               </a:spcAft>
             </a:pPr>
             <a:r>
-              <a:rPr sz="1300">
+              <a:rPr sz="1200">
                 <a:solidFill>
                   <a:srgbClr val="C6A36B"/>
                 </a:solidFill>
@@ -19410,13 +19395,13 @@
               <a:t>◆  </a:t>
             </a:r>
             <a:r>
-              <a:rPr sz="1900" b="0">
-                <a:solidFill>
-                  <a:srgbClr val="26313C"/>
-                </a:solidFill>
-                <a:latin typeface="Calibri"/>
-              </a:rPr>
-              <a:t>No secrets in the repository (.env git-ignored)</a:t>
+              <a:rPr sz="1800" b="0">
+                <a:solidFill>
+                  <a:srgbClr val="26313C"/>
+                </a:solidFill>
+                <a:latin typeface="Calibri"/>
+              </a:rPr>
+              <a:t>Free tier: first request after idle can take ~30 s</a:t>
             </a:r>
           </a:p>
         </p:txBody>

</xml_diff>